<commit_message>
Materiales corridos una semana: guias, cuadernos, kits, programas, Brevo y decks
Todas las clases de adultos empiezan la semana del 19 de octubre (matricula
hasta el domingo 18). Ninos no cambia (lun 19 al lun 7 dic).

- Guias del profesor y cuadernos de Basico 1, Basico 2, Conversacional 1 y
  TOPIK II con fechas +7 dias, ganchos culturales revisados (Pepero Day,
  suneung, Halloween, cambios de hora) y PDF exportados de nuevo.
- Kits de Kiran y Abby v1.2, guias de alumnos y familias, folleto, hoja
  resumen, 6 programas y Programa Completo v1.2 ES/EN (PDF del sitio).
- Correos de Brevo: E5 dom 18, O1 lun 19, R1a-R1f antes de cada clase 1,
  N1 mar 20; preview.js avisa si un correo trae fechas viejas.
- Specs y 16 decks de Basico 1 y 2 regenerados; filas incompletas centradas.
- Destacado INSCRIBETE y cierre del reel de Kiran con domingo 18.
- Mar 8 dic (feriado en Chile) queda "por confirmar" en todo.

Co-Authored-By: Claude Opus 5.5 <noreply@anthropic.com>
</commit_message>
<xml_diff>
--- a/Curriculo/Fase2_Basico1/decks/Basico1_S01_Kiran.pptx
+++ b/Curriculo/Fase2_Basico1/decks/Basico1_S01_Kiran.pptx
@@ -139,7 +139,7 @@
   <p:extLst>
     <p:ext uri="{521415D9-36F7-43E2-AB2F-B90AF26B5E84}">
       <p14:sectionLst xmlns:p14="http://schemas.microsoft.com/office/powerpoint/2010/main">
-        <p14:section name="Semana 1" id="{63AB07B6-1142-7A89-44BF-AF9D6CEC46C3}">
+        <p14:section name="Semana 1" id="{AB62979E-C556-EAD6-2435-B0BFBBAFE96A}">
           <p14:sldIdLst>
             <p14:sldId id="256"/>
             <p14:sldId id="257"/>
@@ -210,7 +210,7 @@
     </p:spTree>
     <p:extLst>
       <p:ext uri="{BB962C8B-B14F-4D97-AF65-F5344CB8AC3E}">
-        <p14:creationId xmlns:p14="http://schemas.microsoft.com/office/powerpoint/2010/main" val="1653887062"/>
+        <p14:creationId xmlns:p14="http://schemas.microsoft.com/office/powerpoint/2010/main" val="877390265"/>
       </p:ext>
     </p:extLst>
   </p:cSld>
@@ -2052,7 +2052,7 @@
           <a:p>
             <a:r>
               <a:rPr lang="en-US" dirty="0"/>
-              <a:t>20:55, 1 min 30 s. Comparte 20 s el Lector (Practicar → chips Vocales y Consonantes; pestaña Progreso). «Unos 30 minutos, antes de la clase 2.» El audio base es el "antes": en la semana 8 se compara con el audio final, así que deben guardarlo. «Todo va en el mensaje del grupo esta noche. Y la clase 2 empieza con un quiz de 5 preguntas en el chat sobre lo de hoy: instala el teclado.»
+              <a:t>20:55, 1 min 30 s. Comparte 20 s el Lector (Practicar → chips Vocales y Consonantes; pestaña Progreso). «Unos 30 minutos, antes de la clase 2.» El audio base es el "antes": en la semana 8 se compara con el audio final, así que deben guardarlo. «Todo va en el mensaje del grupo esta noche. Y la clase 2 empieza con un quiz de 5 preguntas en el chat sobre lo de hoy: instala el teclado.» Si hay alumnos en España, avisa que el domingo 25 cambian de hora: allá la clase 2 es a las 00:00.
 Fuente: Nueva
 Lámina 25</a:t>
             </a:r>
@@ -2855,7 +2855,7 @@
           <a:p>
             <a:r>
               <a:rPr lang="en-US" dirty="0"/>
-              <a:t>≈ 30 s. «Y llegaron en la semana perfecta: hace unos días, el 9 de octubre, Corea del Sur celebró 한글날, el día del alfabeto. Es feriado nacional.» Si preguntan: dejó de ser feriado en 1991 y volvió a serlo en 2013; en Corea del Norte el día del alfabeto es el 15 de enero.
+              <a:t>≈ 30 s. «Y llegaron en buen momento: este mes, el 9 de octubre, Corea del Sur celebró 한글날, el día del alfabeto. Es feriado nacional.» Si preguntan: dejó de ser feriado en 1991 y volvió a serlo en 2013; en Corea del Norte el día del alfabeto es el 15 de enero.
 Imagen: incluida (dibujo de la casa).
 Fuente: Nueva (gancho [YA])
 Lámina 5</a:t>
@@ -9711,7 +9711,7 @@
         </p:nvSpPr>
         <p:spPr>
           <a:xfrm>
-            <a:off x="548640" y="4137660"/>
+            <a:off x="2435352" y="4137660"/>
             <a:ext cx="3544824" cy="2034540"/>
           </a:xfrm>
           <a:prstGeom prst="roundRect">
@@ -9746,7 +9746,7 @@
         </p:blipFill>
         <p:spPr>
           <a:xfrm>
-            <a:off x="621792" y="4192524"/>
+            <a:off x="2508504" y="4192524"/>
             <a:ext cx="1261415" cy="1261415"/>
           </a:xfrm>
           <a:prstGeom prst="rect">
@@ -9762,7 +9762,7 @@
         </p:nvSpPr>
         <p:spPr>
           <a:xfrm>
-            <a:off x="1901495" y="4192524"/>
+            <a:off x="3788207" y="4192524"/>
             <a:ext cx="2155393" cy="1261415"/>
           </a:xfrm>
           <a:prstGeom prst="rect">
@@ -9803,7 +9803,7 @@
         </p:nvSpPr>
         <p:spPr>
           <a:xfrm>
-            <a:off x="594360" y="5527091"/>
+            <a:off x="2481072" y="5527091"/>
             <a:ext cx="3453384" cy="608533"/>
           </a:xfrm>
           <a:prstGeom prst="rect">
@@ -9841,7 +9841,7 @@
         </p:nvSpPr>
         <p:spPr>
           <a:xfrm>
-            <a:off x="4322064" y="4137660"/>
+            <a:off x="6208776" y="4137660"/>
             <a:ext cx="3544824" cy="2034540"/>
           </a:xfrm>
           <a:prstGeom prst="roundRect">
@@ -9876,7 +9876,7 @@
         </p:blipFill>
         <p:spPr>
           <a:xfrm>
-            <a:off x="4395216" y="4192524"/>
+            <a:off x="6281928" y="4192524"/>
             <a:ext cx="1261415" cy="1261415"/>
           </a:xfrm>
           <a:prstGeom prst="rect">
@@ -9892,7 +9892,7 @@
         </p:nvSpPr>
         <p:spPr>
           <a:xfrm>
-            <a:off x="5674919" y="4192524"/>
+            <a:off x="7561631" y="4192524"/>
             <a:ext cx="2155393" cy="1261415"/>
           </a:xfrm>
           <a:prstGeom prst="rect">
@@ -9933,7 +9933,7 @@
         </p:nvSpPr>
         <p:spPr>
           <a:xfrm>
-            <a:off x="4367784" y="5527091"/>
+            <a:off x="6254496" y="5527091"/>
             <a:ext cx="3453384" cy="608533"/>
           </a:xfrm>
           <a:prstGeom prst="rect">
@@ -13105,7 +13105,7 @@
           <p:nvPr>
             <p:extLst>
               <p:ext uri="{D42A27DB-BD31-4B8C-83A1-F6EECF244321}">
-                <p14:modId xmlns:p14="http://schemas.microsoft.com/office/powerpoint/2010/main" val="1808632946"/>
+                <p14:modId xmlns:p14="http://schemas.microsoft.com/office/powerpoint/2010/main" val="3571957954"/>
               </p:ext>
             </p:extLst>
           </p:nvPr>
@@ -17133,7 +17133,7 @@
                   <a:srgbClr val="E8B84B"/>
                 </a:solidFill>
               </a:rPr>
-              <a:t>Martes 13 y jueves 15 de octubre · 20:00 (hora de Chile)</a:t>
+              <a:t>Martes 20 y jueves 22 de octubre · 20:00 (hora de Chile)</a:t>
             </a:r>
             <a:endParaRPr lang="en-US" sz="2200" dirty="0"/>
           </a:p>
@@ -24876,7 +24876,7 @@
                   <a:srgbClr val="4236F6"/>
                 </a:solidFill>
               </a:rPr>
-              <a:t>Antes de tu clase 2 · mar 20 / jue 22 oct, 20:00 (hora de Chile) · todo en el grupo de WhatsApp</a:t>
+              <a:t>Antes de tu clase 2 · mar 27 / jue 29 oct, 20:00 (hora de Chile) · todo en el grupo de WhatsApp</a:t>
             </a:r>
             <a:endParaRPr lang="en-US" sz="1800" dirty="0"/>
           </a:p>
@@ -25266,7 +25266,7 @@
           <p:nvPr>
             <p:extLst>
               <p:ext uri="{D42A27DB-BD31-4B8C-83A1-F6EECF244321}">
-                <p14:modId xmlns:p14="http://schemas.microsoft.com/office/powerpoint/2010/main" val="900222891"/>
+                <p14:modId xmlns:p14="http://schemas.microsoft.com/office/powerpoint/2010/main" val="190149344"/>
               </p:ext>
             </p:extLst>
           </p:nvPr>
@@ -27428,7 +27428,7 @@
           <p:nvPr>
             <p:extLst>
               <p:ext uri="{D42A27DB-BD31-4B8C-83A1-F6EECF244321}">
-                <p14:modId xmlns:p14="http://schemas.microsoft.com/office/powerpoint/2010/main" val="1614915335"/>
+                <p14:modId xmlns:p14="http://schemas.microsoft.com/office/powerpoint/2010/main" val="4257677566"/>
               </p:ext>
             </p:extLst>
           </p:nvPr>
@@ -31233,7 +31233,7 @@
           <p:nvPr>
             <p:extLst>
               <p:ext uri="{D42A27DB-BD31-4B8C-83A1-F6EECF244321}">
-                <p14:modId xmlns:p14="http://schemas.microsoft.com/office/powerpoint/2010/main" val="3147573593"/>
+                <p14:modId xmlns:p14="http://schemas.microsoft.com/office/powerpoint/2010/main" val="755963763"/>
               </p:ext>
             </p:extLst>
           </p:nvPr>
@@ -33036,7 +33036,7 @@
           <p:nvPr>
             <p:extLst>
               <p:ext uri="{D42A27DB-BD31-4B8C-83A1-F6EECF244321}">
-                <p14:modId xmlns:p14="http://schemas.microsoft.com/office/powerpoint/2010/main" val="1424378875"/>
+                <p14:modId xmlns:p14="http://schemas.microsoft.com/office/powerpoint/2010/main" val="3019340466"/>
               </p:ext>
             </p:extLst>
           </p:nvPr>
@@ -35246,7 +35246,7 @@
                   <a:srgbClr val="5C5F6B"/>
                 </a:solidFill>
               </a:rPr>
-              <a:t>Hace unos días, el 9 de octubre, Corea del Sur celebró el día del alfabeto (feriado nacional)</a:t>
+              <a:t>Este mes, el 9 de octubre, Corea del Sur celebró el día del alfabeto (feriado nacional)</a:t>
             </a:r>
             <a:endParaRPr lang="en-US" sz="1700" dirty="0"/>
           </a:p>

</xml_diff>